<commit_message>
docs: add questions and project team closing slide
</commit_message>
<xml_diff>
--- a/FastMCP-Harness - Von der Idee zur Umsetzung.pptx
+++ b/FastMCP-Harness - Von der Idee zur Umsetzung.pptx
@@ -13,6 +13,7 @@
     <p:sldId id="261" r:id="rId13"/>
     <p:sldId id="262" r:id="rId14"/>
     <p:sldId id="263" r:id="rId15"/>
+    <p:sldId id="264" r:id="rId16"/>
   </p:sldIdLst>
   <p:sldSz cx="12191695" cy="6858000" type="screen4x3"/>
   <p:notesSz cx="6858000" cy="9144000"/>
@@ -1040,6 +1041,96 @@
           <a:p>
             <a:r>
               <a:t>• Nicht die Vollproduktion freigeben; Pilot mit Owner, Termin und Abbruchkriterien.</a:t>
+            </a:r>
+          </a:p>
+        </p:txBody>
+      </p:sp>
+      <p:sp>
+        <p:nvSpPr>
+          <p:cNvPr id="4" name="Slide Number Placeholder 3"/>
+          <p:cNvSpPr>
+            <a:spLocks noGrp="1"/>
+          </p:cNvSpPr>
+          <p:nvPr>
+            <p:ph type="sldNum" idx="5" sz="quarter"/>
+          </p:nvPr>
+        </p:nvSpPr>
+        <p:spPr/>
+      </p:sp>
+    </p:spTree>
+  </p:cSld>
+  <p:clrMapOvr>
+    <a:masterClrMapping/>
+  </p:clrMapOvr>
+</p:notes>
+</file>
+
+<file path=ppt/notesSlides/notesSlide9.xml><?xml version="1.0" encoding="utf-8"?>
+<p:notes xmlns:a="http://schemas.openxmlformats.org/drawingml/2006/main" xmlns:p="http://schemas.openxmlformats.org/presentationml/2006/main" xmlns:r="http://schemas.openxmlformats.org/officeDocument/2006/relationships">
+  <p:cSld>
+    <p:spTree>
+      <p:nvGrpSpPr>
+        <p:cNvPr id="1" name=""/>
+        <p:cNvGrpSpPr/>
+        <p:nvPr/>
+      </p:nvGrpSpPr>
+      <p:grpSpPr>
+        <a:xfrm>
+          <a:off x="0" y="0"/>
+          <a:ext cx="0" cy="0"/>
+          <a:chOff x="0" y="0"/>
+          <a:chExt cx="0" cy="0"/>
+        </a:xfrm>
+      </p:grpSpPr>
+      <p:sp>
+        <p:nvSpPr>
+          <p:cNvPr id="2" name="Slide Image Placeholder 1"/>
+          <p:cNvSpPr>
+            <a:spLocks noGrp="1"/>
+          </p:cNvSpPr>
+          <p:nvPr>
+            <p:ph type="sldImg" idx="2"/>
+          </p:nvPr>
+        </p:nvSpPr>
+        <p:spPr/>
+      </p:sp>
+      <p:sp>
+        <p:nvSpPr>
+          <p:cNvPr id="3" name="Notes Placeholder 2"/>
+          <p:cNvSpPr>
+            <a:spLocks noGrp="1"/>
+          </p:cNvSpPr>
+          <p:nvPr>
+            <p:ph type="body" idx="3" sz="quarter"/>
+          </p:nvPr>
+        </p:nvSpPr>
+        <p:spPr/>
+        <p:txBody>
+          <a:bodyPr/>
+          <a:lstStyle/>
+          <a:p>
+            <a:r>
+              <a:t>Vortragshinweise</a:t>
+            </a:r>
+          </a:p>
+          <a:p>
+            <a:r>
+              <a:t>• Die verfügbare Fragezeit am Ende dieser Präsentation ist begrenzt.</a:t>
+            </a:r>
+          </a:p>
+          <a:p>
+            <a:r>
+              <a:t>• Alle Beteiligten sind ausdrücklich eingeladen, das Projektteam im Anschluss zu kontaktieren.</a:t>
+            </a:r>
+          </a:p>
+          <a:p>
+            <a:r>
+              <a:t>• Für komplexe fachliche, organisatorische oder rechtliche Fragen wird ein separater Termin vereinbart.</a:t>
+            </a:r>
+          </a:p>
+          <a:p>
+            <a:r>
+              <a:t>• Kontaktweg, Ansprechpartner und Terminkoordination nach den organisatorischen Vorgaben des Projekts nennen.</a:t>
             </a:r>
           </a:p>
         </p:txBody>
@@ -8124,6 +8215,332 @@
             </a:pPr>
             <a:r>
               <a:t>• Evaluation und Evidence als Pflichtumfang behandeln</a:t>
+            </a:r>
+          </a:p>
+        </p:txBody>
+      </p:sp>
+    </p:spTree>
+  </p:cSld>
+  <p:clrMapOvr>
+    <a:masterClrMapping/>
+  </p:clrMapOvr>
+</p:sld>
+</file>
+
+<file path=ppt/slides/slide9.xml><?xml version="1.0" encoding="utf-8"?>
+<p:sld xmlns:a="http://schemas.openxmlformats.org/drawingml/2006/main" xmlns:p="http://schemas.openxmlformats.org/presentationml/2006/main" xmlns:r="http://schemas.openxmlformats.org/officeDocument/2006/relationships">
+  <p:cSld>
+    <p:bg>
+      <p:bgPr>
+        <a:solidFill>
+          <a:srgbClr val="122B40"/>
+        </a:solidFill>
+        <a:effectLst/>
+      </p:bgPr>
+    </p:bg>
+    <p:spTree>
+      <p:nvGrpSpPr>
+        <p:cNvPr id="1" name=""/>
+        <p:cNvGrpSpPr/>
+        <p:nvPr/>
+      </p:nvGrpSpPr>
+      <p:grpSpPr/>
+      <p:sp>
+        <p:nvSpPr>
+          <p:cNvPr id="2" name="Rectangle 1"/>
+          <p:cNvSpPr/>
+          <p:nvPr/>
+        </p:nvSpPr>
+        <p:spPr>
+          <a:xfrm>
+            <a:off x="0" y="0"/>
+            <a:ext cx="12191695" cy="182880"/>
+          </a:xfrm>
+          <a:prstGeom prst="rect">
+            <a:avLst/>
+          </a:prstGeom>
+          <a:solidFill>
+            <a:srgbClr val="DA9420"/>
+          </a:solidFill>
+          <a:ln>
+            <a:solidFill>
+              <a:srgbClr val="DA9420"/>
+            </a:solidFill>
+          </a:ln>
+        </p:spPr>
+        <p:style>
+          <a:lnRef idx="1">
+            <a:schemeClr val="accent1"/>
+          </a:lnRef>
+          <a:fillRef idx="3">
+            <a:schemeClr val="accent1"/>
+          </a:fillRef>
+          <a:effectRef idx="2">
+            <a:schemeClr val="accent1"/>
+          </a:effectRef>
+          <a:fontRef idx="minor">
+            <a:schemeClr val="lt1"/>
+          </a:fontRef>
+        </p:style>
+        <p:txBody>
+          <a:bodyPr rtlCol="0" anchor="ctr"/>
+          <a:lstStyle/>
+          <a:p>
+            <a:pPr algn="ctr"/>
+          </a:p>
+        </p:txBody>
+      </p:sp>
+      <p:sp>
+        <p:nvSpPr>
+          <p:cNvPr id="3" name="TextBox 2"/>
+          <p:cNvSpPr txBox="1"/>
+          <p:nvPr/>
+        </p:nvSpPr>
+        <p:spPr>
+          <a:xfrm>
+            <a:off x="731520" y="914400"/>
+            <a:ext cx="7315200" cy="320040"/>
+          </a:xfrm>
+          <a:prstGeom prst="rect">
+            <a:avLst/>
+          </a:prstGeom>
+          <a:noFill/>
+        </p:spPr>
+        <p:txBody>
+          <a:bodyPr wrap="square">
+            <a:spAutoFit/>
+          </a:bodyPr>
+          <a:lstStyle/>
+          <a:p>
+            <a:pPr algn="l"/>
+            <a:r>
+              <a:rPr sz="1400" b="1">
+                <a:solidFill>
+                  <a:srgbClr val="DDEBF1"/>
+                </a:solidFill>
+                <a:latin typeface="Aptos"/>
+              </a:rPr>
+              <a:t>AUSTAUSCH UND NÄCHSTE SCHRITTE</a:t>
+            </a:r>
+          </a:p>
+        </p:txBody>
+      </p:sp>
+      <p:sp>
+        <p:nvSpPr>
+          <p:cNvPr id="4" name="TextBox 3"/>
+          <p:cNvSpPr txBox="1"/>
+          <p:nvPr/>
+        </p:nvSpPr>
+        <p:spPr>
+          <a:xfrm>
+            <a:off x="685800" y="1554480"/>
+            <a:ext cx="10058400" cy="594360"/>
+          </a:xfrm>
+          <a:prstGeom prst="rect">
+            <a:avLst/>
+          </a:prstGeom>
+          <a:noFill/>
+        </p:spPr>
+        <p:txBody>
+          <a:bodyPr wrap="square">
+            <a:spAutoFit/>
+          </a:bodyPr>
+          <a:lstStyle/>
+          <a:p>
+            <a:pPr algn="l"/>
+            <a:r>
+              <a:rPr sz="3400" b="1">
+                <a:solidFill>
+                  <a:srgbClr val="FFFFFF"/>
+                </a:solidFill>
+                <a:latin typeface="Aptos"/>
+              </a:rPr>
+              <a:t>Fragen sind willkommen.</a:t>
+            </a:r>
+          </a:p>
+        </p:txBody>
+      </p:sp>
+      <p:sp>
+        <p:nvSpPr>
+          <p:cNvPr id="5" name="TextBox 4"/>
+          <p:cNvSpPr txBox="1"/>
+          <p:nvPr/>
+        </p:nvSpPr>
+        <p:spPr>
+          <a:xfrm>
+            <a:off x="731520" y="2514600"/>
+            <a:ext cx="10058400" cy="411480"/>
+          </a:xfrm>
+          <a:prstGeom prst="rect">
+            <a:avLst/>
+          </a:prstGeom>
+          <a:noFill/>
+        </p:spPr>
+        <p:txBody>
+          <a:bodyPr wrap="square">
+            <a:spAutoFit/>
+          </a:bodyPr>
+          <a:lstStyle/>
+          <a:p>
+            <a:pPr algn="l"/>
+            <a:r>
+              <a:rPr sz="1900" b="0">
+                <a:solidFill>
+                  <a:srgbClr val="DDEBF1"/>
+                </a:solidFill>
+                <a:latin typeface="Aptos"/>
+              </a:rPr>
+              <a:t>Für den heutigen Termin steht nur begrenzte Zeit für Fragen zur Verfügung.</a:t>
+            </a:r>
+          </a:p>
+        </p:txBody>
+      </p:sp>
+      <p:sp>
+        <p:nvSpPr>
+          <p:cNvPr id="6" name="Rounded Rectangle 5"/>
+          <p:cNvSpPr/>
+          <p:nvPr/>
+        </p:nvSpPr>
+        <p:spPr>
+          <a:xfrm>
+            <a:off x="731520" y="3337560"/>
+            <a:ext cx="10607040" cy="1325880"/>
+          </a:xfrm>
+          <a:prstGeom prst="roundRect">
+            <a:avLst/>
+          </a:prstGeom>
+          <a:solidFill>
+            <a:srgbClr val="1F4057"/>
+          </a:solidFill>
+          <a:ln>
+            <a:solidFill>
+              <a:srgbClr val="1F4057"/>
+            </a:solidFill>
+          </a:ln>
+        </p:spPr>
+        <p:style>
+          <a:lnRef idx="1">
+            <a:schemeClr val="accent1"/>
+          </a:lnRef>
+          <a:fillRef idx="3">
+            <a:schemeClr val="accent1"/>
+          </a:fillRef>
+          <a:effectRef idx="2">
+            <a:schemeClr val="accent1"/>
+          </a:effectRef>
+          <a:fontRef idx="minor">
+            <a:schemeClr val="lt1"/>
+          </a:fontRef>
+        </p:style>
+        <p:txBody>
+          <a:bodyPr rtlCol="0" anchor="ctr"/>
+          <a:lstStyle/>
+          <a:p>
+            <a:pPr algn="ctr"/>
+          </a:p>
+        </p:txBody>
+      </p:sp>
+      <p:sp>
+        <p:nvSpPr>
+          <p:cNvPr id="7" name="TextBox 6"/>
+          <p:cNvSpPr txBox="1"/>
+          <p:nvPr/>
+        </p:nvSpPr>
+        <p:spPr>
+          <a:xfrm>
+            <a:off x="1051560" y="3657600"/>
+            <a:ext cx="9875520" cy="365760"/>
+          </a:xfrm>
+          <a:prstGeom prst="rect">
+            <a:avLst/>
+          </a:prstGeom>
+          <a:noFill/>
+        </p:spPr>
+        <p:txBody>
+          <a:bodyPr wrap="square">
+            <a:spAutoFit/>
+          </a:bodyPr>
+          <a:lstStyle/>
+          <a:p>
+            <a:pPr algn="ctr"/>
+            <a:r>
+              <a:rPr sz="1900" b="1">
+                <a:solidFill>
+                  <a:srgbClr val="FFFFFF"/>
+                </a:solidFill>
+                <a:latin typeface="Aptos"/>
+              </a:rPr>
+              <a:t>Bitte sprechen Sie das Projektteam gerne an, um einen separaten Termin zu vereinbaren.</a:t>
+            </a:r>
+          </a:p>
+        </p:txBody>
+      </p:sp>
+      <p:sp>
+        <p:nvSpPr>
+          <p:cNvPr id="8" name="TextBox 7"/>
+          <p:cNvSpPr txBox="1"/>
+          <p:nvPr/>
+        </p:nvSpPr>
+        <p:spPr>
+          <a:xfrm>
+            <a:off x="1051560" y="4160520"/>
+            <a:ext cx="9875520" cy="292608"/>
+          </a:xfrm>
+          <a:prstGeom prst="rect">
+            <a:avLst/>
+          </a:prstGeom>
+          <a:noFill/>
+        </p:spPr>
+        <p:txBody>
+          <a:bodyPr wrap="square">
+            <a:spAutoFit/>
+          </a:bodyPr>
+          <a:lstStyle/>
+          <a:p>
+            <a:pPr algn="ctr"/>
+            <a:r>
+              <a:rPr sz="1500" b="0">
+                <a:solidFill>
+                  <a:srgbClr val="DDEBF1"/>
+                </a:solidFill>
+                <a:latin typeface="Aptos"/>
+              </a:rPr>
+              <a:t>Dort können Ihre Fragen ausführlich, fachlich fundiert und bestmöglich beantwortet werden.</a:t>
+            </a:r>
+          </a:p>
+        </p:txBody>
+      </p:sp>
+      <p:sp>
+        <p:nvSpPr>
+          <p:cNvPr id="9" name="TextBox 8"/>
+          <p:cNvSpPr txBox="1"/>
+          <p:nvPr/>
+        </p:nvSpPr>
+        <p:spPr>
+          <a:xfrm>
+            <a:off x="731520" y="5806440"/>
+            <a:ext cx="5486400" cy="320040"/>
+          </a:xfrm>
+          <a:prstGeom prst="rect">
+            <a:avLst/>
+          </a:prstGeom>
+          <a:noFill/>
+        </p:spPr>
+        <p:txBody>
+          <a:bodyPr wrap="square">
+            <a:spAutoFit/>
+          </a:bodyPr>
+          <a:lstStyle/>
+          <a:p>
+            <a:pPr algn="l"/>
+            <a:r>
+              <a:rPr sz="1500" b="1">
+                <a:solidFill>
+                  <a:srgbClr val="DDEBF1"/>
+                </a:solidFill>
+                <a:latin typeface="Aptos"/>
+              </a:rPr>
+              <a:t>Vielen Dank für Ihre Aufmerksamkeit.</a:t>
             </a:r>
           </a:p>
         </p:txBody>

</xml_diff>